<commit_message>
Add Word versions of project documentation; add real roll numbers to deck
</commit_message>
<xml_diff>
--- a/documentation/Customer_Churn_Prediction_Project_Documentation.pptx
+++ b/documentation/Customer_Churn_Prediction_Project_Documentation.pptx
@@ -3525,7 +3525,7 @@
                 </a:solidFill>
                 <a:latin typeface="Segoe UI"/>
               </a:rPr>
-              <a:t>Roll No. 24CSR___</a:t>
+              <a:t>Roll No. 24CSR306</a:t>
             </a:r>
           </a:p>
         </p:txBody>
@@ -3580,7 +3580,7 @@
                 </a:solidFill>
                 <a:latin typeface="Segoe UI"/>
               </a:rPr>
-              <a:t>Roll No. 24CSR___</a:t>
+              <a:t>Roll No. 24CSR321</a:t>
             </a:r>
           </a:p>
         </p:txBody>
@@ -3635,7 +3635,7 @@
                 </a:solidFill>
                 <a:latin typeface="Segoe UI"/>
               </a:rPr>
-              <a:t>Roll No. 24CSR___</a:t>
+              <a:t>Roll No. 24CSR345</a:t>
             </a:r>
           </a:p>
         </p:txBody>

</xml_diff>